<commit_message>
Final simulation results and regenerated manuscript/tables/figures
Run complete: phase1 (50 sims), sensitivity (30 sims), non-linearity (30 sims), real-data. Summary CSVs, manuscript, tables and figures regenerated from the full results with no hard-coded numbers.

Co-Authored-By: Tatsuki Onishi <bougtoir@gmail.com>
</commit_message>
<xml_diff>
--- a/results/figures/pptx/figures.pptx
+++ b/results/figures/pptx/figures.pptx
@@ -7,6 +7,7 @@
   <p:sldIdLst>
     <p:sldId id="256" r:id="rId7"/>
     <p:sldId id="257" r:id="rId8"/>
+    <p:sldId id="258" r:id="rId9"/>
   </p:sldIdLst>
   <p:sldSz cx="12191695" cy="6858000" type="screen4x3"/>
   <p:notesSz cx="6858000" cy="9144000"/>
@@ -3184,6 +3185,110 @@
 </file>
 
 <file path=ppt/slides/slide2.xml><?xml version="1.0" encoding="utf-8"?>
+<p:sld xmlns:a="http://schemas.openxmlformats.org/drawingml/2006/main" xmlns:p="http://schemas.openxmlformats.org/presentationml/2006/main" xmlns:r="http://schemas.openxmlformats.org/officeDocument/2006/relationships">
+  <p:cSld>
+    <p:spTree>
+      <p:nvGrpSpPr>
+        <p:cNvPr id="1" name=""/>
+        <p:cNvGrpSpPr/>
+        <p:nvPr/>
+      </p:nvGrpSpPr>
+      <p:grpSpPr/>
+      <p:sp>
+        <p:nvSpPr>
+          <p:cNvPr id="2" name="TextBox 1"/>
+          <p:cNvSpPr txBox="1"/>
+          <p:nvPr/>
+        </p:nvSpPr>
+        <p:spPr>
+          <a:xfrm>
+            <a:off x="457200" y="274320"/>
+            <a:ext cx="10972800" cy="548640"/>
+          </a:xfrm>
+          <a:prstGeom prst="rect">
+            <a:avLst/>
+          </a:prstGeom>
+          <a:noFill/>
+        </p:spPr>
+        <p:txBody>
+          <a:bodyPr wrap="none">
+            <a:spAutoFit/>
+          </a:bodyPr>
+          <a:lstStyle/>
+          <a:p>
+            <a:pPr>
+              <a:defRPr sz="2000" b="1"/>
+            </a:pPr>
+            <a:r>
+              <a:t>Figure 2</a:t>
+            </a:r>
+          </a:p>
+        </p:txBody>
+      </p:sp>
+      <p:pic>
+        <p:nvPicPr>
+          <p:cNvPr id="3" name="Picture 2" descr="fig2_sensitivity_bias.png"/>
+          <p:cNvPicPr>
+            <a:picLocks noChangeAspect="1"/>
+          </p:cNvPicPr>
+          <p:nvPr/>
+        </p:nvPicPr>
+        <p:blipFill>
+          <a:blip r:embed="rId2"/>
+          <a:stretch>
+            <a:fillRect/>
+          </a:stretch>
+        </p:blipFill>
+        <p:spPr>
+          <a:xfrm>
+            <a:off x="914400" y="1097280"/>
+            <a:ext cx="10362895" cy="5181448"/>
+          </a:xfrm>
+          <a:prstGeom prst="rect">
+            <a:avLst/>
+          </a:prstGeom>
+        </p:spPr>
+      </p:pic>
+      <p:sp>
+        <p:nvSpPr>
+          <p:cNvPr id="4" name="TextBox 3"/>
+          <p:cNvSpPr txBox="1"/>
+          <p:nvPr/>
+        </p:nvSpPr>
+        <p:spPr>
+          <a:xfrm>
+            <a:off x="457200" y="5943600"/>
+            <a:ext cx="10972800" cy="731520"/>
+          </a:xfrm>
+          <a:prstGeom prst="rect">
+            <a:avLst/>
+          </a:prstGeom>
+          <a:noFill/>
+        </p:spPr>
+        <p:txBody>
+          <a:bodyPr wrap="none">
+            <a:spAutoFit/>
+          </a:bodyPr>
+          <a:lstStyle/>
+          <a:p>
+            <a:pPr>
+              <a:defRPr sz="1400"/>
+            </a:pPr>
+            <a:r>
+              <a:t>Sensitivity of bias reduction to Z→X influence.</a:t>
+            </a:r>
+          </a:p>
+        </p:txBody>
+      </p:sp>
+    </p:spTree>
+  </p:cSld>
+  <p:clrMapOvr>
+    <a:masterClrMapping/>
+  </p:clrMapOvr>
+</p:sld>
+</file>
+
+<file path=ppt/slides/slide3.xml><?xml version="1.0" encoding="utf-8"?>
 <p:sld xmlns:a="http://schemas.openxmlformats.org/drawingml/2006/main" xmlns:p="http://schemas.openxmlformats.org/presentationml/2006/main" xmlns:r="http://schemas.openxmlformats.org/officeDocument/2006/relationships">
   <p:cSld>
     <p:spTree>

</xml_diff>